<commit_message>
docs: corriger l'accès de la Direction au journal d'audit dans les présentations
Vérifié par test : la Direction ne lit le journal (espace d'administration)
que si son compte a l'accès équipe (is_staff), non activé par défaut. Le
tableau des droits, la page Direction et la partie Sécurité du Word, ainsi
que la diapositive des droits du PowerPoint, le précisent maintenant.

Co-Authored-By: Claude Sonnet 5 <noreply@anthropic.com>
</commit_message>
<xml_diff>
--- a/Presentation-ERP-DEN-Source.pptx
+++ b/Presentation-ERP-DEN-Source.pptx
@@ -12644,7 +12644,7 @@
                           <a:ea typeface="Calibri" pitchFamily="34" charset="-122"/>
                           <a:cs typeface="Calibri" pitchFamily="34" charset="-120"/>
                         </a:rPr>
-                        <a:t>Lit</a:t>
+                        <a:t>Lit*</a:t>
                       </a:r>
                       <a:endParaRPr lang="en-US" sz="1200" dirty="0">
                         <a:latin typeface="Calibri" charset="0"/>
@@ -13030,8 +13030,8 @@
         </p:nvSpPr>
         <p:spPr>
           <a:xfrm>
-            <a:off x="548640" y="6172200"/>
-            <a:ext cx="11094415" cy="274320"/>
+            <a:off x="548640" y="6089904"/>
+            <a:ext cx="11094415" cy="365760"/>
           </a:xfrm>
           <a:prstGeom prst="rect">
             <a:avLst/>
@@ -13047,7 +13047,7 @@
               <a:buNone/>
             </a:pPr>
             <a:r>
-              <a:rPr lang="en-US" sz="1150" i="1" dirty="0">
+              <a:rPr lang="en-US" sz="1100" i="1" dirty="0">
                 <a:solidFill>
                   <a:srgbClr val="6B6B6B"/>
                 </a:solidFill>
@@ -13055,9 +13055,9 @@
                 <a:ea typeface="Calibri" pitchFamily="34" charset="-122"/>
                 <a:cs typeface="Calibri" pitchFamily="34" charset="-120"/>
               </a:rPr>
-              <a:t>Gère = consulter et modifier · Lit = lecture seule · un droit de validation vient aussi de la hiérarchie (congés) ou de la Direction (factures).</a:t>
-            </a:r>
-            <a:endParaRPr lang="en-US" sz="1150" dirty="0"/>
+              <a:t>Gère = consulter et modifier · Lit = lecture seule · Lit* = via l'espace d'administration, accès à activer sur le compte · la validation vient aussi de la hiérarchie (congés) ou de la Direction (factures).</a:t>
+            </a:r>
+            <a:endParaRPr lang="en-US" sz="1100" dirty="0"/>
           </a:p>
         </p:txBody>
       </p:sp>

</xml_diff>